<commit_message>
Testadviezen doorgevoerd in alle documenten
De vier regels uit de test staan nu in de prompt zelf, op werkblad 3 en op
slide 3 van werkcollege 3: spreiding op ordening en drager, beperking tot
beschikbaar materiaal, en een afsluitende as-matrix die de AI moet uitschrijven.

Het losse v2-bestand is samengevoegd in de hoofdprompt en verwijderd. De
versienotitie is er bewust uit gelaten: de prompt hoort geen verwijzing naar
zijn eigen testgeschiedenis te bevatten.

Co-Authored-By: Claude Opus 5 <noreply@anthropic.com>
</commit_message>
<xml_diff>
--- a/Werkcollege-3-vijf-ontwerpen.pptx
+++ b/Werkcollege-3-vijf-ontwerpen.pptx
@@ -649,7 +649,7 @@
           <a:lstStyle/>
           <a:p>
             <a:r>
-              <a:t>De prompt staat op werkblad 3. Het geheim zit in twee dingen. Ten eerste dwing je de AI om op vijf assen positie te kiezen, zodat de ontwerpen niet in het midden blijven hangen. Ten tweede vraag je per ontwerp waar het faalt, en verbied je een aanbeveling. Zonder die twee regels krijg je vijf even brave voorstellen waar je niet uit kunt kiezen. En dat kiezen is nou juist jouw werk.  [4:00 - 7:00]</a:t>
+              <a:t>De prompt staat op werkblad 3. Het geheim zit in twee dingen. Ten eerste dwing je de AI om op vijf assen positie te kiezen, zodat de ontwerpen niet in het midden blijven hangen. Ten tweede vraag je per ontwerp waar het faalt, en verbied je een aanbeveling. Zonder die regels krijg je vijf even brave voorstellen waar je niet uit kunt kiezen. En ten derde, in de praktijk het belangrijkst: je laat de AI aan het eind een tabel maken met de positie van elk ontwerp op elke as. Een controle die niemand kan nalezen, gebeurt namelijk niet.  [4:00 - 7:00]</a:t>
             </a:r>
           </a:p>
         </p:txBody>
@@ -6681,16 +6681,16 @@
               </a:lnSpc>
             </a:pPr>
             <a:r>
-              <a:rPr sz="1700" b="0">
+              <a:rPr sz="1500" b="0">
                 <a:solidFill>
                   <a:srgbClr val="000000"/>
                 </a:solidFill>
                 <a:latin typeface="Arial"/>
               </a:rPr>
-              <a:t>En twee regels die het verschil maken: </a:t>
-            </a:r>
-            <a:r>
-              <a:rPr sz="1700" b="1">
+              <a:t>Plus drie regels: </a:t>
+            </a:r>
+            <a:r>
+              <a:rPr sz="1500" b="1">
                 <a:solidFill>
                   <a:srgbClr val="000000"/>
                 </a:solidFill>
@@ -6699,25 +6699,43 @@
               <a:t>geen aanbeveling</a:t>
             </a:r>
             <a:r>
-              <a:rPr sz="1700" b="0">
+              <a:rPr sz="1500" b="0">
                 <a:solidFill>
                   <a:srgbClr val="000000"/>
                 </a:solidFill>
                 <a:latin typeface="Arial"/>
               </a:rPr>
+              <a:t>, </a:t>
+            </a:r>
+            <a:r>
+              <a:rPr sz="1500" b="1">
+                <a:solidFill>
+                  <a:srgbClr val="000000"/>
+                </a:solidFill>
+                <a:latin typeface="Arial"/>
+              </a:rPr>
+              <a:t>benoem waar elk ontwerp faalt</a:t>
+            </a:r>
+            <a:r>
+              <a:rPr sz="1500" b="0">
+                <a:solidFill>
+                  <a:srgbClr val="000000"/>
+                </a:solidFill>
+                <a:latin typeface="Arial"/>
+              </a:rPr>
               <a:t>, en </a:t>
             </a:r>
             <a:r>
-              <a:rPr sz="1700" b="1">
+              <a:rPr sz="1500" b="1">
                 <a:solidFill>
                   <a:srgbClr val="000000"/>
                 </a:solidFill>
                 <a:latin typeface="Arial"/>
               </a:rPr>
-              <a:t>benoem per ontwerp waar het faalt</a:t>
-            </a:r>
-            <a:r>
-              <a:rPr sz="1700" b="0">
+              <a:t>laat de AI zijn eigen spreiding narekenen</a:t>
+            </a:r>
+            <a:r>
+              <a:rPr sz="1500" b="0">
                 <a:solidFill>
                   <a:srgbClr val="000000"/>
                 </a:solidFill>

</xml_diff>